<commit_message>
fix: Chinese keyword translation pipeline for V4 Pro
Root cause: _translate_keywords() had two failures:
1. V4 Pro thinking mode consumed 256-token budget -> Chinese untranslated
2. deep_search.py passed raw Chinese keywords to Google Patents (EN-only)

Fix: disable thinking mode, max_tokens 256->512, better prompt;
translate all keywords at deep_search.py pipeline start.

Co-Authored-By: Claude <noreply@anthropic.com>
</commit_message>
<xml_diff>
--- a/ppt/FORGE_AI_Introduction_Deck.pptx
+++ b/ppt/FORGE_AI_Introduction_Deck.pptx
@@ -1525,7 +1525,7 @@
         </p:nvSpPr>
         <p:spPr>
           <a:xfrm>
-            <a:off x="731520" y="1280160"/>
+            <a:off x="727875" y="1531620"/>
             <a:ext cx="6400800" cy="1005840"/>
           </a:xfrm>
           <a:prstGeom prst="rect">
@@ -1564,8 +1564,8 @@
         </p:nvSpPr>
         <p:spPr>
           <a:xfrm>
-            <a:off x="731520" y="2286000"/>
-            <a:ext cx="6400800" cy="502920"/>
+            <a:off x="727874" y="3127099"/>
+            <a:ext cx="7044525" cy="502920"/>
           </a:xfrm>
           <a:prstGeom prst="rect">
             <a:avLst/>
@@ -1589,48 +1589,9 @@
                 <a:ea typeface="Calibri" pitchFamily="34" charset="-122"/>
                 <a:cs typeface="Calibri" pitchFamily="34" charset="-120"/>
               </a:rPr>
-              <a:t>Revolutionize Your Innovation Process</a:t>
+              <a:t>Revolutionize Your Innovation Process Today</a:t>
             </a:r>
             <a:endParaRPr lang="en-US" sz="2200" dirty="0"/>
-          </a:p>
-        </p:txBody>
-      </p:sp>
-      <p:sp>
-        <p:nvSpPr>
-          <p:cNvPr id="7" name="Text 5"/>
-          <p:cNvSpPr/>
-          <p:nvPr/>
-        </p:nvSpPr>
-        <p:spPr>
-          <a:xfrm>
-            <a:off x="731520" y="2788920"/>
-            <a:ext cx="6400800" cy="411480"/>
-          </a:xfrm>
-          <a:prstGeom prst="rect">
-            <a:avLst/>
-          </a:prstGeom>
-          <a:noFill/>
-          <a:ln/>
-        </p:spPr>
-        <p:txBody>
-          <a:bodyPr wrap="square" lIns="0" tIns="0" rIns="0" bIns="0" rtlCol="0" anchor="ctr"/>
-          <a:lstStyle/>
-          <a:p>
-            <a:pPr marL="0" indent="0">
-              <a:buNone/>
-            </a:pPr>
-            <a:r>
-              <a:rPr lang="en-US" sz="1500" dirty="0">
-                <a:solidFill>
-                  <a:srgbClr val="64748B"/>
-                </a:solidFill>
-                <a:latin typeface="Calibri" pitchFamily="34" charset="0"/>
-                <a:ea typeface="Calibri" pitchFamily="34" charset="-122"/>
-                <a:cs typeface="Calibri" pitchFamily="34" charset="-120"/>
-              </a:rPr>
-              <a:t>The AI-Native R&amp;D Platform</a:t>
-            </a:r>
-            <a:endParaRPr lang="en-US" sz="1500" dirty="0"/>
           </a:p>
         </p:txBody>
       </p:sp>
@@ -1709,6 +1670,55 @@
               <a:t>1 / 10</a:t>
             </a:r>
             <a:endParaRPr lang="en-US" sz="800" dirty="0"/>
+          </a:p>
+        </p:txBody>
+      </p:sp>
+      <p:sp>
+        <p:nvSpPr>
+          <p:cNvPr id="11" name="TextBox 10">
+            <a:extLst>
+              <a:ext uri="{FF2B5EF4-FFF2-40B4-BE49-F238E27FC236}">
+                <a16:creationId xmlns:a16="http://schemas.microsoft.com/office/drawing/2014/main" id="{C3CF09F7-8CFA-2526-1F30-97D9EEC317CA}"/>
+              </a:ext>
+            </a:extLst>
+          </p:cNvPr>
+          <p:cNvSpPr txBox="1"/>
+          <p:nvPr/>
+        </p:nvSpPr>
+        <p:spPr>
+          <a:xfrm>
+            <a:off x="639908" y="2683354"/>
+            <a:ext cx="7707466" cy="375872"/>
+          </a:xfrm>
+          <a:prstGeom prst="rect">
+            <a:avLst/>
+          </a:prstGeom>
+          <a:noFill/>
+        </p:spPr>
+        <p:txBody>
+          <a:bodyPr wrap="square">
+            <a:spAutoFit/>
+          </a:bodyPr>
+          <a:lstStyle/>
+          <a:p>
+            <a:pPr marL="0" indent="0">
+              <a:lnSpc>
+                <a:spcPct val="125000"/>
+              </a:lnSpc>
+              <a:buNone/>
+            </a:pPr>
+            <a:r>
+              <a:rPr lang="en-US" altLang="zh-CN" sz="1600" b="1" dirty="0">
+                <a:solidFill>
+                  <a:srgbClr val="EBE8E3"/>
+                </a:solidFill>
+                <a:latin typeface="Georgia" pitchFamily="34" charset="0"/>
+                <a:ea typeface="Georgia" pitchFamily="34" charset="-122"/>
+                <a:cs typeface="Georgia" pitchFamily="34" charset="-120"/>
+              </a:rPr>
+              <a:t>The world's best materials are built by the world's slowest R&amp;D process.</a:t>
+            </a:r>
+            <a:endParaRPr lang="en-US" altLang="zh-CN" sz="1600" dirty="0"/>
           </a:p>
         </p:txBody>
       </p:sp>
@@ -2836,7 +2846,7 @@
         </p:nvSpPr>
         <p:spPr>
           <a:xfrm>
-            <a:off x="640080" y="2007790"/>
+            <a:off x="640080" y="2061130"/>
             <a:ext cx="3474720" cy="502920"/>
           </a:xfrm>
           <a:prstGeom prst="rect">
@@ -3471,7 +3481,7 @@
           </p:nvSpPr>
           <p:spPr>
             <a:xfrm>
-              <a:off x="1154430" y="2906529"/>
+              <a:off x="1154430" y="2942590"/>
               <a:ext cx="2446020" cy="685800"/>
             </a:xfrm>
             <a:prstGeom prst="rect">
@@ -3514,6 +3524,11 @@
                 </a:rPr>
                 <a:t>manual, not reusable     </a:t>
               </a:r>
+            </a:p>
+            <a:p>
+              <a:pPr marL="0" indent="0" algn="ctr">
+                <a:buNone/>
+              </a:pPr>
               <a:endParaRPr lang="en-US" sz="1800" b="1" dirty="0">
                 <a:solidFill>
                   <a:srgbClr val="10B981"/>
@@ -3528,6 +3543,17 @@
                 <a:buNone/>
               </a:pPr>
               <a:r>
+                <a:rPr lang="en-US" b="1" dirty="0">
+                  <a:solidFill>
+                    <a:srgbClr val="10B981"/>
+                  </a:solidFill>
+                  <a:latin typeface="Arial Black" pitchFamily="34" charset="0"/>
+                  <a:ea typeface="Arial Black" pitchFamily="34" charset="-122"/>
+                  <a:cs typeface="Arial Black" pitchFamily="34" charset="-120"/>
+                </a:rPr>
+                <a:t>8</a:t>
+              </a:r>
+              <a:r>
                 <a:rPr lang="en-US" sz="1800" b="1" dirty="0">
                   <a:solidFill>
                     <a:srgbClr val="10B981"/>
@@ -3536,7 +3562,7 @@
                   <a:ea typeface="Arial Black" pitchFamily="34" charset="-122"/>
                   <a:cs typeface="Arial Black" pitchFamily="34" charset="-120"/>
                 </a:rPr>
-                <a:t>5 minutes  </a:t>
+                <a:t> minutes  </a:t>
               </a:r>
             </a:p>
             <a:p>
@@ -3661,6 +3687,55 @@
               <a:t>2 / 10</a:t>
             </a:r>
             <a:endParaRPr lang="en-US" sz="800" dirty="0"/>
+          </a:p>
+        </p:txBody>
+      </p:sp>
+      <p:sp>
+        <p:nvSpPr>
+          <p:cNvPr id="30" name="Arrow: Down 29">
+            <a:extLst>
+              <a:ext uri="{FF2B5EF4-FFF2-40B4-BE49-F238E27FC236}">
+                <a16:creationId xmlns:a16="http://schemas.microsoft.com/office/drawing/2014/main" id="{7C3F23A2-42D4-41A5-EEFB-D7A3A0810B96}"/>
+              </a:ext>
+            </a:extLst>
+          </p:cNvPr>
+          <p:cNvSpPr/>
+          <p:nvPr/>
+        </p:nvSpPr>
+        <p:spPr>
+          <a:xfrm>
+            <a:off x="2282757" y="3392520"/>
+            <a:ext cx="233464" cy="278860"/>
+          </a:xfrm>
+          <a:prstGeom prst="downArrow">
+            <a:avLst/>
+          </a:prstGeom>
+          <a:solidFill>
+            <a:schemeClr val="bg1"/>
+          </a:solidFill>
+        </p:spPr>
+        <p:style>
+          <a:lnRef idx="2">
+            <a:schemeClr val="accent1">
+              <a:shade val="15000"/>
+            </a:schemeClr>
+          </a:lnRef>
+          <a:fillRef idx="1">
+            <a:schemeClr val="accent1"/>
+          </a:fillRef>
+          <a:effectRef idx="0">
+            <a:schemeClr val="accent1"/>
+          </a:effectRef>
+          <a:fontRef idx="minor">
+            <a:schemeClr val="lt1"/>
+          </a:fontRef>
+        </p:style>
+        <p:txBody>
+          <a:bodyPr rtlCol="0" anchor="ctr"/>
+          <a:lstStyle/>
+          <a:p>
+            <a:pPr algn="ctr"/>
+            <a:endParaRPr lang="zh-CN" altLang="en-US"/>
           </a:p>
         </p:txBody>
       </p:sp>
@@ -3730,7 +3805,7 @@
                 <a:ea typeface="Arial Black" pitchFamily="34" charset="-122"/>
                 <a:cs typeface="Arial Black" pitchFamily="34" charset="-120"/>
               </a:rPr>
-              <a:t>The FORGE AI Way</a:t>
+              <a:t>The FORGE AI Way   </a:t>
             </a:r>
             <a:endParaRPr lang="en-US" sz="3000" dirty="0"/>
           </a:p>
@@ -3757,11 +3832,8 @@
           <a:bodyPr wrap="square" lIns="0" tIns="0" rIns="0" bIns="0" rtlCol="0" anchor="ctr"/>
           <a:lstStyle/>
           <a:p>
-            <a:pPr marL="0" indent="0">
-              <a:buNone/>
-            </a:pPr>
-            <a:r>
-              <a:rPr lang="en-US" sz="1300" dirty="0">
+            <a:r>
+              <a:rPr lang="en-US" altLang="zh-CN" sz="1400" dirty="0">
                 <a:solidFill>
                   <a:srgbClr val="14B8A6"/>
                 </a:solidFill>
@@ -3769,9 +3841,20 @@
                 <a:ea typeface="Calibri" pitchFamily="34" charset="-122"/>
                 <a:cs typeface="Calibri" pitchFamily="34" charset="-120"/>
               </a:rPr>
-              <a:t>One research question in → a complete R&amp;D report out</a:t>
-            </a:r>
-            <a:endParaRPr lang="en-US" sz="1300" dirty="0"/>
+              <a:t>Revolutionize Your Innovation Process</a:t>
+            </a:r>
+            <a:r>
+              <a:rPr lang="en-US" altLang="zh-CN" sz="1300" dirty="0">
+                <a:solidFill>
+                  <a:srgbClr val="14B8A6"/>
+                </a:solidFill>
+                <a:latin typeface="Calibri" pitchFamily="34" charset="0"/>
+                <a:ea typeface="Calibri" pitchFamily="34" charset="-122"/>
+                <a:cs typeface="Calibri" pitchFamily="34" charset="-120"/>
+              </a:rPr>
+              <a:t> in 8 Minutes </a:t>
+            </a:r>
+            <a:endParaRPr lang="en-US" altLang="zh-CN" sz="1400" dirty="0"/>
           </a:p>
         </p:txBody>
       </p:sp>
@@ -4172,24 +4255,7 @@
                 <a:ea typeface="Calibri" pitchFamily="34" charset="-122"/>
                 <a:cs typeface="Calibri" pitchFamily="34" charset="-120"/>
               </a:rPr>
-              <a:t>6 global patent</a:t>
-            </a:r>
-            <a:endParaRPr lang="en-US" sz="1000" dirty="0"/>
-          </a:p>
-          <a:p>
-            <a:pPr marL="0" indent="0" algn="ctr">
-              <a:buNone/>
-            </a:pPr>
-            <a:r>
-              <a:rPr lang="en-US" sz="1000" dirty="0">
-                <a:solidFill>
-                  <a:srgbClr val="64748B"/>
-                </a:solidFill>
-                <a:latin typeface="Calibri" pitchFamily="34" charset="0"/>
-                <a:ea typeface="Calibri" pitchFamily="34" charset="-122"/>
-                <a:cs typeface="Calibri" pitchFamily="34" charset="-120"/>
-              </a:rPr>
-              <a:t>sources scanned</a:t>
+              <a:t>Recursive Convergence across multiple sources</a:t>
             </a:r>
             <a:endParaRPr lang="en-US" sz="1000" dirty="0"/>
           </a:p>
@@ -4400,9 +4466,8 @@
                 <a:ea typeface="Calibri" pitchFamily="34" charset="-122"/>
                 <a:cs typeface="Calibri" pitchFamily="34" charset="-120"/>
               </a:rPr>
-              <a:t>Full text analysis</a:t>
-            </a:r>
-            <a:endParaRPr lang="en-US" sz="1000" dirty="0"/>
+              <a:t>Map-reduce</a:t>
+            </a:r>
           </a:p>
           <a:p>
             <a:pPr marL="0" indent="0" algn="ctr">
@@ -4417,7 +4482,7 @@
                 <a:ea typeface="Calibri" pitchFamily="34" charset="-122"/>
                 <a:cs typeface="Calibri" pitchFamily="34" charset="-120"/>
               </a:rPr>
-              <a:t>X-Y extraction</a:t>
+              <a:t>Millions of texts processed in 5 minutes</a:t>
             </a:r>
             <a:endParaRPr lang="en-US" sz="1000" dirty="0"/>
           </a:p>

</xml_diff>